<commit_message>
fix(navigator): align portal paths and tool checkpoints
Reuse the prepared knowledge connection, validate the manual Anonymous OpenAPI prerequisite, and document current guardrail, MCP approval and memory controls. Separate grounded discovery from confirmation, reject unsolicited writes, and describe actual recovery and specialist-routing evidence. Restore verified images in the guides and update the narrative, facilitator coverage and lab-flow deck.

Co-authored-by: Copilot App <223556219+Copilot@users.noreply.github.com>
</commit_message>
<xml_diff>
--- a/deck/LiveWell-Lab-Flow.pptx
+++ b/deck/LiveWell-Lab-Flow.pptx
@@ -5884,7 +5884,7 @@
         <p:spPr>
           <a:xfrm>
             <a:off x="457200" y="2395728"/>
-            <a:ext cx="5897880" cy="731520"/>
+            <a:ext cx="5897880" cy="896112"/>
           </a:xfrm>
           <a:prstGeom prst="rect">
             <a:avLst/>
@@ -5934,7 +5934,7 @@
                 </a:solidFill>
                 <a:latin typeface="Segoe UI"/>
               </a:rPr>
-              <a:t> “It's hazy today. What can I do indoors near Woodlands, and can you sign me up?”</a:t>
+              <a:t> “It's hazy today. Look up my profile, use knowledge_base_retrieve to search the LiveWell guides for haze-safe activity advice, then use find_activities to list indoor community activities near Woodlands. Show me the options first.”</a:t>
             </a:r>
           </a:p>
           <a:p>
@@ -5950,7 +5950,7 @@
                 </a:solidFill>
                 <a:latin typeface="Segoe UI"/>
               </a:rPr>
-              <a:t>The sign-up is a real write, so it needs his approval.</a:t>
+              <a:t>The sign-up changes synthetic demo state, so it needs his approval.</a:t>
             </a:r>
           </a:p>
         </p:txBody>
@@ -5963,7 +5963,7 @@
         </p:nvSpPr>
         <p:spPr>
           <a:xfrm>
-            <a:off x="457200" y="3172968"/>
+            <a:off x="457200" y="3337560"/>
             <a:ext cx="5897880" cy="237744"/>
           </a:xfrm>
           <a:prstGeom prst="rect">
@@ -5999,7 +5999,7 @@
         </p:nvSpPr>
         <p:spPr>
           <a:xfrm>
-            <a:off x="502920" y="3465575"/>
+            <a:off x="502920" y="3630168"/>
             <a:ext cx="274320" cy="274320"/>
           </a:xfrm>
           <a:prstGeom prst="ellipse">
@@ -6054,8 +6054,8 @@
         </p:nvSpPr>
         <p:spPr>
           <a:xfrm>
-            <a:off x="868680" y="3428999"/>
-            <a:ext cx="5486400" cy="385572"/>
+            <a:off x="868680" y="3593591"/>
+            <a:ext cx="5486400" cy="358140"/>
           </a:xfrm>
           <a:prstGeom prst="rect">
             <a:avLst/>
@@ -6080,7 +6080,7 @@
                 </a:solidFill>
                 <a:latin typeface="Segoe UI"/>
               </a:rPr>
-              <a:t>Switch the model to </a:t>
+              <a:t>Switch to </a:t>
             </a:r>
             <a:r>
               <a:rPr sz="1080" i="0" b="0">
@@ -6098,7 +6098,7 @@
                 </a:solidFill>
                 <a:latin typeface="Segoe UI"/>
               </a:rPr>
-              <a:t>, then add the OpenAPI tool </a:t>
+              <a:t>; add </a:t>
             </a:r>
             <a:r>
               <a:rPr sz="1080" i="0" b="0">
@@ -6116,25 +6116,7 @@
                 </a:solidFill>
                 <a:latin typeface="Segoe UI"/>
               </a:rPr>
-              <a:t> (Builder: the </a:t>
-            </a:r>
-            <a:r>
-              <a:rPr sz="1080" i="0" b="0">
-                <a:solidFill>
-                  <a:srgbClr val="0B2E59"/>
-                </a:solidFill>
-                <a:latin typeface="Consolas"/>
-              </a:rPr>
-              <a:t>get_citizen_profile</a:t>
-            </a:r>
-            <a:r>
-              <a:rPr sz="1080" i="0" b="0">
-                <a:solidFill>
-                  <a:srgbClr val="333333"/>
-                </a:solidFill>
-                <a:latin typeface="Segoe UI"/>
-              </a:rPr>
-              <a:t> function).</a:t>
+              <a:t> using the prepared Anonymous connection and inline spec.</a:t>
             </a:r>
           </a:p>
         </p:txBody>
@@ -6147,7 +6129,7 @@
         </p:nvSpPr>
         <p:spPr>
           <a:xfrm>
-            <a:off x="502920" y="3851147"/>
+            <a:off x="502920" y="3988307"/>
             <a:ext cx="274320" cy="274320"/>
           </a:xfrm>
           <a:prstGeom prst="ellipse">
@@ -6202,8 +6184,8 @@
         </p:nvSpPr>
         <p:spPr>
           <a:xfrm>
-            <a:off x="868680" y="3814572"/>
-            <a:ext cx="5486400" cy="385572"/>
+            <a:off x="868680" y="3951732"/>
+            <a:ext cx="5486400" cy="358140"/>
           </a:xfrm>
           <a:prstGeom prst="rect">
             <a:avLst/>
@@ -6228,7 +6210,7 @@
                 </a:solidFill>
                 <a:latin typeface="Segoe UI"/>
               </a:rPr>
-              <a:t>Add </a:t>
+              <a:t>Add activities MCP; auto-approve only </a:t>
             </a:r>
             <a:r>
               <a:rPr sz="1080" i="0" b="0">
@@ -6237,7 +6219,7 @@
                 </a:solidFill>
                 <a:latin typeface="Consolas"/>
               </a:rPr>
-              <a:t>livewell-activities-mcp</a:t>
+              <a:t>find_activities</a:t>
             </a:r>
             <a:r>
               <a:rPr sz="1080" i="0" b="0">
@@ -6246,25 +6228,7 @@
                 </a:solidFill>
                 <a:latin typeface="Segoe UI"/>
               </a:rPr>
-              <a:t> and require approval for </a:t>
-            </a:r>
-            <a:r>
-              <a:rPr sz="1080" i="0" b="0">
-                <a:solidFill>
-                  <a:srgbClr val="0B2E59"/>
-                </a:solidFill>
-                <a:latin typeface="Consolas"/>
-              </a:rPr>
-              <a:t>register_interest</a:t>
-            </a:r>
-            <a:r>
-              <a:rPr sz="1080" i="0" b="0">
-                <a:solidFill>
-                  <a:srgbClr val="333333"/>
-                </a:solidFill>
-                <a:latin typeface="Segoe UI"/>
-              </a:rPr>
-              <a:t>.</a:t>
+              <a:t>, never registration.</a:t>
             </a:r>
           </a:p>
         </p:txBody>
@@ -6277,7 +6241,7 @@
         </p:nvSpPr>
         <p:spPr>
           <a:xfrm>
-            <a:off x="502920" y="4236720"/>
+            <a:off x="502920" y="4346448"/>
             <a:ext cx="274320" cy="274320"/>
           </a:xfrm>
           <a:prstGeom prst="ellipse">
@@ -6332,8 +6296,8 @@
         </p:nvSpPr>
         <p:spPr>
           <a:xfrm>
-            <a:off x="868680" y="4200144"/>
-            <a:ext cx="5486400" cy="385572"/>
+            <a:off x="868680" y="4309872"/>
+            <a:ext cx="5486400" cy="358140"/>
           </a:xfrm>
           <a:prstGeom prst="rect">
             <a:avLst/>
@@ -6352,49 +6316,40 @@
               </a:spcAft>
             </a:pPr>
             <a:r>
+              <a:rPr sz="1080" i="0" b="1">
+                <a:solidFill>
+                  <a:srgbClr val="333333"/>
+                </a:solidFill>
+                <a:latin typeface="Segoe UI"/>
+              </a:rPr>
+              <a:t>Memory → Add → Auto-create memory store</a:t>
+            </a:r>
+            <a:r>
               <a:rPr sz="1080" i="0" b="0">
                 <a:solidFill>
                   <a:srgbClr val="333333"/>
                 </a:solidFill>
                 <a:latin typeface="Segoe UI"/>
               </a:rPr>
-              <a:t>Enable </a:t>
-            </a:r>
-            <a:r>
-              <a:rPr sz="1080" i="0" b="1">
+              <a:t> (preview); append </a:t>
+            </a:r>
+            <a:r>
+              <a:rPr sz="1080" i="0" b="0">
+                <a:solidFill>
+                  <a:srgbClr val="0B2E59"/>
+                </a:solidFill>
+                <a:latin typeface="Consolas"/>
+              </a:rPr>
+              <a:t>tools</a:t>
+            </a:r>
+            <a:r>
+              <a:rPr sz="1080" i="0" b="0">
                 <a:solidFill>
                   <a:srgbClr val="333333"/>
                 </a:solidFill>
                 <a:latin typeface="Segoe UI"/>
               </a:rPr>
-              <a:t>Memory</a:t>
-            </a:r>
-            <a:r>
-              <a:rPr sz="1080" i="0" b="0">
-                <a:solidFill>
-                  <a:srgbClr val="333333"/>
-                </a:solidFill>
-                <a:latin typeface="Segoe UI"/>
-              </a:rPr>
-              <a:t> (preview) and append the </a:t>
-            </a:r>
-            <a:r>
-              <a:rPr sz="1080" i="0" b="0">
-                <a:solidFill>
-                  <a:srgbClr val="0B2E59"/>
-                </a:solidFill>
-                <a:latin typeface="Consolas"/>
-              </a:rPr>
-              <a:t>tools</a:t>
-            </a:r>
-            <a:r>
-              <a:rPr sz="1080" i="0" b="0">
-                <a:solidFill>
-                  <a:srgbClr val="333333"/>
-                </a:solidFill>
-                <a:latin typeface="Segoe UI"/>
-              </a:rPr>
-              <a:t> block.</a:t>
+              <a:t>, set the evidence schema, save.</a:t>
             </a:r>
           </a:p>
         </p:txBody>
@@ -6407,7 +6362,7 @@
         </p:nvSpPr>
         <p:spPr>
           <a:xfrm>
-            <a:off x="502920" y="4622292"/>
+            <a:off x="502920" y="4704588"/>
             <a:ext cx="274320" cy="274320"/>
           </a:xfrm>
           <a:prstGeom prst="ellipse">
@@ -6462,8 +6417,8 @@
         </p:nvSpPr>
         <p:spPr>
           <a:xfrm>
-            <a:off x="868680" y="4585716"/>
-            <a:ext cx="5486400" cy="385572"/>
+            <a:off x="868680" y="4668012"/>
+            <a:ext cx="5486400" cy="358140"/>
           </a:xfrm>
           <a:prstGeom prst="rect">
             <a:avLst/>
@@ -6488,25 +6443,7 @@
                 </a:solidFill>
                 <a:latin typeface="Segoe UI"/>
               </a:rPr>
-              <a:t>Send </a:t>
-            </a:r>
-            <a:r>
-              <a:rPr sz="1080" i="0" b="0">
-                <a:solidFill>
-                  <a:srgbClr val="0B2E59"/>
-                </a:solidFill>
-                <a:latin typeface="Consolas"/>
-              </a:rPr>
-              <a:t>lab3_profile_tailored</a:t>
-            </a:r>
-            <a:r>
-              <a:rPr sz="1080" i="0" b="0">
-                <a:solidFill>
-                  <a:srgbClr val="333333"/>
-                </a:solidFill>
-                <a:latin typeface="Segoe UI"/>
-              </a:rPr>
-              <a:t>: the advice uses Rahim's profile.</a:t>
+              <a:t>Run profile advice, then discovery: profile → knowledge retrieval → indoor activity options.</a:t>
             </a:r>
           </a:p>
         </p:txBody>
@@ -6519,7 +6456,7 @@
         </p:nvSpPr>
         <p:spPr>
           <a:xfrm>
-            <a:off x="502920" y="5007864"/>
+            <a:off x="502920" y="5062728"/>
             <a:ext cx="274320" cy="274320"/>
           </a:xfrm>
           <a:prstGeom prst="ellipse">
@@ -6574,8 +6511,8 @@
         </p:nvSpPr>
         <p:spPr>
           <a:xfrm>
-            <a:off x="868680" y="4971288"/>
-            <a:ext cx="5486400" cy="385572"/>
+            <a:off x="868680" y="5026152"/>
+            <a:ext cx="5486400" cy="358140"/>
           </a:xfrm>
           <a:prstGeom prst="rect">
             <a:avLst/>
@@ -6609,7 +6546,7 @@
                 </a:solidFill>
                 <a:latin typeface="Consolas"/>
               </a:rPr>
-              <a:t>lab3_hazy_indoor_signup</a:t>
+              <a:t>lab3_signup_confirm</a:t>
             </a:r>
             <a:r>
               <a:rPr sz="1080" i="0" b="0">
@@ -6618,7 +6555,7 @@
                 </a:solidFill>
                 <a:latin typeface="Segoe UI"/>
               </a:rPr>
-              <a:t>: indoor options near Woodlands, then </a:t>
+              <a:t>, inspect the proposed activity, then </a:t>
             </a:r>
             <a:r>
               <a:rPr sz="1080" i="0" b="1">
@@ -6627,7 +6564,7 @@
                 </a:solidFill>
                 <a:latin typeface="Segoe UI"/>
               </a:rPr>
-              <a:t>Approve</a:t>
+              <a:t>Approve once</a:t>
             </a:r>
             <a:r>
               <a:rPr sz="1080" i="0" b="0">
@@ -6636,7 +6573,7 @@
                 </a:solidFill>
                 <a:latin typeface="Segoe UI"/>
               </a:rPr>
-              <a:t> the sign-up.</a:t>
+              <a:t>.</a:t>
             </a:r>
           </a:p>
         </p:txBody>
@@ -6649,7 +6586,7 @@
         </p:nvSpPr>
         <p:spPr>
           <a:xfrm>
-            <a:off x="502920" y="5393436"/>
+            <a:off x="502920" y="5420867"/>
             <a:ext cx="274320" cy="274320"/>
           </a:xfrm>
           <a:prstGeom prst="ellipse">
@@ -6704,8 +6641,8 @@
         </p:nvSpPr>
         <p:spPr>
           <a:xfrm>
-            <a:off x="868680" y="5356860"/>
-            <a:ext cx="5486400" cy="385572"/>
+            <a:off x="868680" y="5384292"/>
+            <a:ext cx="5486400" cy="358140"/>
           </a:xfrm>
           <a:prstGeom prst="rect">
             <a:avLst/>
@@ -6730,86 +6667,40 @@
                 </a:solidFill>
                 <a:latin typeface="Segoe UI"/>
               </a:rPr>
-              <a:t>State a preference, start a new chat and check the coach remembers it.</a:t>
-            </a:r>
-          </a:p>
-        </p:txBody>
-      </p:sp>
-      <p:sp>
-        <p:nvSpPr>
-          <p:cNvPr id="27" name="Rectangle 26"/>
-          <p:cNvSpPr/>
-          <p:nvPr/>
-        </p:nvSpPr>
-        <p:spPr>
-          <a:xfrm>
-            <a:off x="6583680" y="1298448"/>
-            <a:ext cx="5166360" cy="4023360"/>
+              <a:t>State preferences, wait for memory, then use a new chat. Optional A2A: verify both actual calls.</a:t>
+            </a:r>
+          </a:p>
+        </p:txBody>
+      </p:sp>
+      <p:pic>
+        <p:nvPicPr>
+          <p:cNvPr id="27" name="Picture 26" descr="image.png"/>
+          <p:cNvPicPr>
+            <a:picLocks noChangeAspect="1"/>
+          </p:cNvPicPr>
+          <p:nvPr/>
+        </p:nvPicPr>
+        <p:blipFill>
+          <a:blip r:embed="rId3"/>
+          <a:stretch>
+            <a:fillRect/>
+          </a:stretch>
+        </p:blipFill>
+        <p:spPr>
+          <a:xfrm>
+            <a:off x="7025238" y="1298448"/>
+            <a:ext cx="4283242" cy="4023360"/>
           </a:xfrm>
           <a:prstGeom prst="rect">
             <a:avLst/>
           </a:prstGeom>
-          <a:solidFill>
-            <a:srgbClr val="F4F8FA"/>
-          </a:solidFill>
           <a:ln w="12700">
             <a:solidFill>
               <a:srgbClr val="D7E2EA"/>
             </a:solidFill>
           </a:ln>
-          <a:effectLst/>
-        </p:spPr>
-        <p:style>
-          <a:lnRef idx="1">
-            <a:schemeClr val="accent1"/>
-          </a:lnRef>
-          <a:fillRef idx="3">
-            <a:schemeClr val="accent1"/>
-          </a:fillRef>
-          <a:effectRef idx="2">
-            <a:schemeClr val="accent1"/>
-          </a:effectRef>
-          <a:fontRef idx="minor">
-            <a:schemeClr val="lt1"/>
-          </a:fontRef>
-        </p:style>
-        <p:txBody>
-          <a:bodyPr rtlCol="0" anchor="ctr" wrap="square" lIns="73152" rIns="73152" bIns="36576"/>
-          <a:lstStyle/>
-          <a:p>
-            <a:pPr algn="l">
-              <a:spcAft>
-                <a:spcPts val="200"/>
-              </a:spcAft>
-            </a:pPr>
-            <a:r>
-              <a:rPr sz="1100" i="0" b="1">
-                <a:solidFill>
-                  <a:srgbClr val="0B2E59"/>
-                </a:solidFill>
-                <a:latin typeface="Segoe UI"/>
-              </a:rPr>
-              <a:t>Text-only reference</a:t>
-            </a:r>
-          </a:p>
-          <a:p>
-            <a:pPr algn="l">
-              <a:spcAft>
-                <a:spcPts val="200"/>
-              </a:spcAft>
-            </a:pPr>
-            <a:r>
-              <a:rPr sz="1100" i="0" b="0">
-                <a:solidFill>
-                  <a:srgbClr val="333333"/>
-                </a:solidFill>
-                <a:latin typeface="Segoe UI"/>
-              </a:rPr>
-              <a:t>Follow the current Navigator steps and copy blocks. The older screenshot is awaiting a live refresh.</a:t>
-            </a:r>
-          </a:p>
-        </p:txBody>
-      </p:sp>
+        </p:spPr>
+      </p:pic>
       <p:sp>
         <p:nvSpPr>
           <p:cNvPr id="28" name="TextBox 27"/>
@@ -6844,25 +6735,7 @@
                 </a:solidFill>
                 <a:latin typeface="Segoe UI"/>
               </a:rPr>
-              <a:t>The write waits for you: </a:t>
-            </a:r>
-            <a:r>
-              <a:rPr sz="950" i="1" b="0">
-                <a:solidFill>
-                  <a:srgbClr val="0B2E59"/>
-                </a:solidFill>
-                <a:latin typeface="Consolas"/>
-              </a:rPr>
-              <a:t>register_interest</a:t>
-            </a:r>
-            <a:r>
-              <a:rPr sz="950" i="1" b="0">
-                <a:solidFill>
-                  <a:srgbClr val="333333"/>
-                </a:solidFill>
-                <a:latin typeface="Segoe UI"/>
-              </a:rPr>
-              <a:t> only runs after Approve.</a:t>
+              <a:t>After separate confirmation, inspect the proposed write and choose Approve once.</a:t>
             </a:r>
           </a:p>
         </p:txBody>
@@ -19913,7 +19786,7 @@
                 </a:solidFill>
                 <a:latin typeface="Segoe UI"/>
               </a:rPr>
-              <a:t>“It's hazy today. What can I do indoors near Woodlands, and can you sign me up?”</a:t>
+              <a:t>“It's hazy today. Look up my profile, use knowledge_base_retrieve to search the LiveWell guides for haze-safe activity advice, then use find_activities to list indoor community activities near Woodlands. Show me the options first.”</a:t>
             </a:r>
           </a:p>
         </p:txBody>
@@ -23291,7 +23164,7 @@
                           </a:solidFill>
                           <a:latin typeface="Segoe UI"/>
                         </a:rPr>
-                        <a:t>It's hazy today. What can I do indoors near Woodlands, and can you sign me up?</a:t>
+                        <a:t>It's hazy today. Look up my profile, use knowledge_base_retrieve to search the LiveWell guides for haze-safe activity advice, then use find_activities to list indoor community activities near Woodlands. Show me the options first.</a:t>
                       </a:r>
                     </a:p>
                   </a:txBody>
@@ -26336,81 +26209,35 @@
           </a:p>
         </p:txBody>
       </p:sp>
-      <p:sp>
-        <p:nvSpPr>
-          <p:cNvPr id="27" name="Rectangle 26"/>
-          <p:cNvSpPr/>
-          <p:nvPr/>
-        </p:nvSpPr>
-        <p:spPr>
-          <a:xfrm>
-            <a:off x="6583680" y="1298448"/>
-            <a:ext cx="5166360" cy="4023360"/>
+      <p:pic>
+        <p:nvPicPr>
+          <p:cNvPr id="27" name="Picture 26" descr="image.png"/>
+          <p:cNvPicPr>
+            <a:picLocks noChangeAspect="1"/>
+          </p:cNvPicPr>
+          <p:nvPr/>
+        </p:nvPicPr>
+        <p:blipFill>
+          <a:blip r:embed="rId3"/>
+          <a:stretch>
+            <a:fillRect/>
+          </a:stretch>
+        </p:blipFill>
+        <p:spPr>
+          <a:xfrm>
+            <a:off x="6583680" y="1436984"/>
+            <a:ext cx="5166360" cy="3746287"/>
           </a:xfrm>
           <a:prstGeom prst="rect">
             <a:avLst/>
           </a:prstGeom>
-          <a:solidFill>
-            <a:srgbClr val="F4F8FA"/>
-          </a:solidFill>
           <a:ln w="12700">
             <a:solidFill>
               <a:srgbClr val="D7E2EA"/>
             </a:solidFill>
           </a:ln>
-          <a:effectLst/>
-        </p:spPr>
-        <p:style>
-          <a:lnRef idx="1">
-            <a:schemeClr val="accent1"/>
-          </a:lnRef>
-          <a:fillRef idx="3">
-            <a:schemeClr val="accent1"/>
-          </a:fillRef>
-          <a:effectRef idx="2">
-            <a:schemeClr val="accent1"/>
-          </a:effectRef>
-          <a:fontRef idx="minor">
-            <a:schemeClr val="lt1"/>
-          </a:fontRef>
-        </p:style>
-        <p:txBody>
-          <a:bodyPr rtlCol="0" anchor="ctr" wrap="square" lIns="73152" rIns="73152" bIns="36576"/>
-          <a:lstStyle/>
-          <a:p>
-            <a:pPr algn="l">
-              <a:spcAft>
-                <a:spcPts val="200"/>
-              </a:spcAft>
-            </a:pPr>
-            <a:r>
-              <a:rPr sz="1100" i="0" b="1">
-                <a:solidFill>
-                  <a:srgbClr val="0B2E59"/>
-                </a:solidFill>
-                <a:latin typeface="Segoe UI"/>
-              </a:rPr>
-              <a:t>Text-only reference</a:t>
-            </a:r>
-          </a:p>
-          <a:p>
-            <a:pPr algn="l">
-              <a:spcAft>
-                <a:spcPts val="200"/>
-              </a:spcAft>
-            </a:pPr>
-            <a:r>
-              <a:rPr sz="1100" i="0" b="0">
-                <a:solidFill>
-                  <a:srgbClr val="333333"/>
-                </a:solidFill>
-                <a:latin typeface="Segoe UI"/>
-              </a:rPr>
-              <a:t>Follow the current Navigator steps and copy blocks. The older screenshot is awaiting a live refresh.</a:t>
-            </a:r>
-          </a:p>
-        </p:txBody>
-      </p:sp>
+        </p:spPr>
+      </p:pic>
       <p:sp>
         <p:nvSpPr>
           <p:cNvPr id="28" name="TextBox 27"/>
@@ -26445,25 +26272,7 @@
                 </a:solidFill>
                 <a:latin typeface="Segoe UI"/>
               </a:rPr>
-              <a:t>One chat span under the agent, no tool calls, and the </a:t>
-            </a:r>
-            <a:r>
-              <a:rPr sz="950" i="1" b="0">
-                <a:solidFill>
-                  <a:srgbClr val="0B2E59"/>
-                </a:solidFill>
-                <a:latin typeface="Consolas"/>
-              </a:rPr>
-              <a:t>base</a:t>
-            </a:r>
-            <a:r>
-              <a:rPr sz="950" i="1" b="0">
-                <a:solidFill>
-                  <a:srgbClr val="333333"/>
-                </a:solidFill>
-                <a:latin typeface="Segoe UI"/>
-              </a:rPr>
-              <a:t> block as the system message.</a:t>
+              <a:t>One chat span per answer, no tool calls; the conversation includes the greeting and refusal.</a:t>
             </a:r>
           </a:p>
         </p:txBody>
@@ -27291,7 +27100,7 @@
                 </a:solidFill>
                 <a:latin typeface="Segoe UI"/>
               </a:rPr>
-              <a:t>Knowledge → Add → Connect to Foundry IQ</a:t>
+              <a:t>Knowledge → Add → Available knowledge bases</a:t>
             </a:r>
             <a:r>
               <a:rPr sz="1080" i="0" b="0">
@@ -27300,7 +27109,7 @@
                 </a:solidFill>
                 <a:latin typeface="Segoe UI"/>
               </a:rPr>
-              <a:t> and pick </a:t>
+              <a:t>: pick </a:t>
             </a:r>
             <a:r>
               <a:rPr sz="1080" i="0" b="0">
@@ -27310,6 +27119,24 @@
                 <a:latin typeface="Consolas"/>
               </a:rPr>
               <a:t>livewell-guides-kb</a:t>
+            </a:r>
+            <a:r>
+              <a:rPr sz="1080" i="0" b="0">
+                <a:solidFill>
+                  <a:srgbClr val="333333"/>
+                </a:solidFill>
+                <a:latin typeface="Segoe UI"/>
+              </a:rPr>
+              <a:t> via </a:t>
+            </a:r>
+            <a:r>
+              <a:rPr sz="1080" i="0" b="0">
+                <a:solidFill>
+                  <a:srgbClr val="0B2E59"/>
+                </a:solidFill>
+                <a:latin typeface="Consolas"/>
+              </a:rPr>
+              <a:t>livewell-guides-kb-mcp</a:t>
             </a:r>
             <a:r>
               <a:rPr sz="1080" i="0" b="0">
@@ -27928,81 +27755,35 @@
           </a:p>
         </p:txBody>
       </p:sp>
-      <p:sp>
-        <p:nvSpPr>
-          <p:cNvPr id="27" name="Rectangle 26"/>
-          <p:cNvSpPr/>
-          <p:nvPr/>
-        </p:nvSpPr>
-        <p:spPr>
-          <a:xfrm>
-            <a:off x="6583680" y="1298448"/>
-            <a:ext cx="5166360" cy="4023360"/>
+      <p:pic>
+        <p:nvPicPr>
+          <p:cNvPr id="27" name="Picture 26" descr="image.png"/>
+          <p:cNvPicPr>
+            <a:picLocks noChangeAspect="1"/>
+          </p:cNvPicPr>
+          <p:nvPr/>
+        </p:nvPicPr>
+        <p:blipFill>
+          <a:blip r:embed="rId3"/>
+          <a:stretch>
+            <a:fillRect/>
+          </a:stretch>
+        </p:blipFill>
+        <p:spPr>
+          <a:xfrm>
+            <a:off x="7628719" y="1298448"/>
+            <a:ext cx="3076280" cy="4023360"/>
           </a:xfrm>
           <a:prstGeom prst="rect">
             <a:avLst/>
           </a:prstGeom>
-          <a:solidFill>
-            <a:srgbClr val="F4F8FA"/>
-          </a:solidFill>
           <a:ln w="12700">
             <a:solidFill>
               <a:srgbClr val="D7E2EA"/>
             </a:solidFill>
           </a:ln>
-          <a:effectLst/>
-        </p:spPr>
-        <p:style>
-          <a:lnRef idx="1">
-            <a:schemeClr val="accent1"/>
-          </a:lnRef>
-          <a:fillRef idx="3">
-            <a:schemeClr val="accent1"/>
-          </a:fillRef>
-          <a:effectRef idx="2">
-            <a:schemeClr val="accent1"/>
-          </a:effectRef>
-          <a:fontRef idx="minor">
-            <a:schemeClr val="lt1"/>
-          </a:fontRef>
-        </p:style>
-        <p:txBody>
-          <a:bodyPr rtlCol="0" anchor="ctr" wrap="square" lIns="73152" rIns="73152" bIns="36576"/>
-          <a:lstStyle/>
-          <a:p>
-            <a:pPr algn="l">
-              <a:spcAft>
-                <a:spcPts val="200"/>
-              </a:spcAft>
-            </a:pPr>
-            <a:r>
-              <a:rPr sz="1100" i="0" b="1">
-                <a:solidFill>
-                  <a:srgbClr val="0B2E59"/>
-                </a:solidFill>
-                <a:latin typeface="Segoe UI"/>
-              </a:rPr>
-              <a:t>Text-only reference</a:t>
-            </a:r>
-          </a:p>
-          <a:p>
-            <a:pPr algn="l">
-              <a:spcAft>
-                <a:spcPts val="200"/>
-              </a:spcAft>
-            </a:pPr>
-            <a:r>
-              <a:rPr sz="1100" i="0" b="0">
-                <a:solidFill>
-                  <a:srgbClr val="333333"/>
-                </a:solidFill>
-                <a:latin typeface="Segoe UI"/>
-              </a:rPr>
-              <a:t>Follow the current Navigator steps and copy blocks. The older screenshot is awaiting a live refresh.</a:t>
-            </a:r>
-          </a:p>
-        </p:txBody>
-      </p:sp>
+        </p:spPr>
+      </p:pic>
       <p:sp>
         <p:nvSpPr>
           <p:cNvPr id="28" name="TextBox 27"/>
@@ -29448,81 +29229,35 @@
           </a:p>
         </p:txBody>
       </p:sp>
-      <p:sp>
-        <p:nvSpPr>
-          <p:cNvPr id="28" name="Rectangle 27"/>
-          <p:cNvSpPr/>
-          <p:nvPr/>
-        </p:nvSpPr>
-        <p:spPr>
-          <a:xfrm>
-            <a:off x="6583680" y="1554480"/>
-            <a:ext cx="5166360" cy="2286000"/>
+      <p:pic>
+        <p:nvPicPr>
+          <p:cNvPr id="28" name="Picture 27" descr="image.png"/>
+          <p:cNvPicPr>
+            <a:picLocks noChangeAspect="1"/>
+          </p:cNvPicPr>
+          <p:nvPr/>
+        </p:nvPicPr>
+        <p:blipFill>
+          <a:blip r:embed="rId3"/>
+          <a:stretch>
+            <a:fillRect/>
+          </a:stretch>
+        </p:blipFill>
+        <p:spPr>
+          <a:xfrm>
+            <a:off x="7995845" y="1554480"/>
+            <a:ext cx="2342029" cy="2286000"/>
           </a:xfrm>
           <a:prstGeom prst="rect">
             <a:avLst/>
           </a:prstGeom>
-          <a:solidFill>
-            <a:srgbClr val="F4F8FA"/>
-          </a:solidFill>
           <a:ln w="12700">
             <a:solidFill>
               <a:srgbClr val="D7E2EA"/>
             </a:solidFill>
           </a:ln>
-          <a:effectLst/>
-        </p:spPr>
-        <p:style>
-          <a:lnRef idx="1">
-            <a:schemeClr val="accent1"/>
-          </a:lnRef>
-          <a:fillRef idx="3">
-            <a:schemeClr val="accent1"/>
-          </a:fillRef>
-          <a:effectRef idx="2">
-            <a:schemeClr val="accent1"/>
-          </a:effectRef>
-          <a:fontRef idx="minor">
-            <a:schemeClr val="lt1"/>
-          </a:fontRef>
-        </p:style>
-        <p:txBody>
-          <a:bodyPr rtlCol="0" anchor="ctr" wrap="square" lIns="73152" rIns="73152" bIns="36576"/>
-          <a:lstStyle/>
-          <a:p>
-            <a:pPr algn="l">
-              <a:spcAft>
-                <a:spcPts val="200"/>
-              </a:spcAft>
-            </a:pPr>
-            <a:r>
-              <a:rPr sz="1100" i="0" b="1">
-                <a:solidFill>
-                  <a:srgbClr val="0B2E59"/>
-                </a:solidFill>
-                <a:latin typeface="Segoe UI"/>
-              </a:rPr>
-              <a:t>Text-only reference</a:t>
-            </a:r>
-          </a:p>
-          <a:p>
-            <a:pPr algn="l">
-              <a:spcAft>
-                <a:spcPts val="200"/>
-              </a:spcAft>
-            </a:pPr>
-            <a:r>
-              <a:rPr sz="1100" i="0" b="0">
-                <a:solidFill>
-                  <a:srgbClr val="333333"/>
-                </a:solidFill>
-                <a:latin typeface="Segoe UI"/>
-              </a:rPr>
-              <a:t>Follow the current Navigator steps and copy blocks. The older screenshot is awaiting a live refresh.</a:t>
-            </a:r>
-          </a:p>
-        </p:txBody>
-      </p:sp>
+        </p:spPr>
+      </p:pic>
       <p:sp>
         <p:nvSpPr>
           <p:cNvPr id="29" name="TextBox 28"/>
@@ -29559,81 +29294,35 @@
           </a:p>
         </p:txBody>
       </p:sp>
-      <p:sp>
-        <p:nvSpPr>
-          <p:cNvPr id="30" name="Rectangle 29"/>
-          <p:cNvSpPr/>
-          <p:nvPr/>
-        </p:nvSpPr>
-        <p:spPr>
-          <a:xfrm>
-            <a:off x="6583680" y="4206240"/>
-            <a:ext cx="5166360" cy="1143000"/>
+      <p:pic>
+        <p:nvPicPr>
+          <p:cNvPr id="30" name="Picture 29" descr="image.png"/>
+          <p:cNvPicPr>
+            <a:picLocks noChangeAspect="1"/>
+          </p:cNvPicPr>
+          <p:nvPr/>
+        </p:nvPicPr>
+        <p:blipFill>
+          <a:blip r:embed="rId4"/>
+          <a:stretch>
+            <a:fillRect/>
+          </a:stretch>
+        </p:blipFill>
+        <p:spPr>
+          <a:xfrm>
+            <a:off x="7710231" y="4206240"/>
+            <a:ext cx="2913256" cy="1143000"/>
           </a:xfrm>
           <a:prstGeom prst="rect">
             <a:avLst/>
           </a:prstGeom>
-          <a:solidFill>
-            <a:srgbClr val="F4F8FA"/>
-          </a:solidFill>
           <a:ln w="12700">
             <a:solidFill>
               <a:srgbClr val="D7E2EA"/>
             </a:solidFill>
           </a:ln>
-          <a:effectLst/>
-        </p:spPr>
-        <p:style>
-          <a:lnRef idx="1">
-            <a:schemeClr val="accent1"/>
-          </a:lnRef>
-          <a:fillRef idx="3">
-            <a:schemeClr val="accent1"/>
-          </a:fillRef>
-          <a:effectRef idx="2">
-            <a:schemeClr val="accent1"/>
-          </a:effectRef>
-          <a:fontRef idx="minor">
-            <a:schemeClr val="lt1"/>
-          </a:fontRef>
-        </p:style>
-        <p:txBody>
-          <a:bodyPr rtlCol="0" anchor="ctr" wrap="square" lIns="73152" rIns="73152" bIns="36576"/>
-          <a:lstStyle/>
-          <a:p>
-            <a:pPr algn="l">
-              <a:spcAft>
-                <a:spcPts val="200"/>
-              </a:spcAft>
-            </a:pPr>
-            <a:r>
-              <a:rPr sz="1100" i="0" b="1">
-                <a:solidFill>
-                  <a:srgbClr val="0B2E59"/>
-                </a:solidFill>
-                <a:latin typeface="Segoe UI"/>
-              </a:rPr>
-              <a:t>Text-only reference</a:t>
-            </a:r>
-          </a:p>
-          <a:p>
-            <a:pPr algn="l">
-              <a:spcAft>
-                <a:spcPts val="200"/>
-              </a:spcAft>
-            </a:pPr>
-            <a:r>
-              <a:rPr sz="1100" i="0" b="0">
-                <a:solidFill>
-                  <a:srgbClr val="333333"/>
-                </a:solidFill>
-                <a:latin typeface="Segoe UI"/>
-              </a:rPr>
-              <a:t>Follow the current Navigator steps and copy blocks. The older screenshot is awaiting a live refresh.</a:t>
-            </a:r>
-          </a:p>
-        </p:txBody>
-      </p:sp>
+        </p:spPr>
+      </p:pic>
       <p:sp>
         <p:nvSpPr>
           <p:cNvPr id="31" name="TextBox 30"/>

</xml_diff>